<commit_message>
Refine Transformation Engineering and Edison week
Co-authored-by: Cursor <cursoragent@cursor.com>
</commit_message>
<xml_diff>
--- a/production/releases/chapter-06/06-ch6-energy-transformations-slides.pptx
+++ b/production/releases/chapter-06/06-ch6-energy-transformations-slides.pptx
@@ -3240,7 +3240,7 @@
                 </a:solidFill>
                 <a:latin typeface="Arial"/>
               </a:rPr>
-              <a:t>Chapter 6 · Grade 4 · Week 7</a:t>
+              <a:t>Chapter 6 · Grade 4 · Week 4</a:t>
             </a:r>
           </a:p>
         </p:txBody>
@@ -5167,7 +5167,7 @@
                 </a:solidFill>
                 <a:latin typeface="Arial"/>
               </a:rPr>
-              <a:t>Notebook — Insert 2</a:t>
+              <a:t>Notes — Insert 2</a:t>
             </a:r>
           </a:p>
         </p:txBody>
@@ -8104,7 +8104,7 @@
                 </a:solidFill>
                 <a:latin typeface="Arial"/>
               </a:rPr>
-              <a:t>Notebook — Insert 3</a:t>
+              <a:t>Notes — Insert 3</a:t>
             </a:r>
           </a:p>
         </p:txBody>
@@ -8227,7 +8227,7 @@
                 </a:solidFill>
                 <a:latin typeface="Arial"/>
               </a:rPr>
-              <a:t>NOTEBOOK</a:t>
+              <a:t>NOTES</a:t>
             </a:r>
           </a:p>
         </p:txBody>
@@ -12172,7 +12172,7 @@
                 </a:solidFill>
                 <a:latin typeface="Arial"/>
               </a:rPr>
-              <a:t>Week 7 exit</a:t>
+              <a:t>Week 4 exit</a:t>
             </a:r>
           </a:p>
         </p:txBody>
@@ -12466,7 +12466,7 @@
                 </a:solidFill>
                 <a:latin typeface="Arial"/>
               </a:rPr>
-              <a:t>Chapter 6 · Grade 4 · Week 8</a:t>
+              <a:t>Chapter 6 · Grade 4 · Week 4</a:t>
             </a:r>
           </a:p>
         </p:txBody>
@@ -14877,7 +14877,7 @@
                 </a:solidFill>
                 <a:latin typeface="Arial"/>
               </a:rPr>
-              <a:t>Notebook — Insert 4</a:t>
+              <a:t>Notes — Insert 4</a:t>
             </a:r>
           </a:p>
         </p:txBody>
@@ -15000,7 +15000,7 @@
                 </a:solidFill>
                 <a:latin typeface="Arial"/>
               </a:rPr>
-              <a:t>NOTEBOOK</a:t>
+              <a:t>NOTES</a:t>
             </a:r>
           </a:p>
         </p:txBody>
@@ -16178,7 +16178,7 @@
                 </a:solidFill>
                 <a:latin typeface="Arial"/>
               </a:rPr>
-              <a:t>Notebook — Insert 5</a:t>
+              <a:t>Notes — Insert 5</a:t>
             </a:r>
           </a:p>
         </p:txBody>
@@ -16301,7 +16301,7 @@
                 </a:solidFill>
                 <a:latin typeface="Arial"/>
               </a:rPr>
-              <a:t>NOTEBOOK</a:t>
+              <a:t>NOTES</a:t>
             </a:r>
           </a:p>
         </p:txBody>
@@ -19226,7 +19226,7 @@
                 </a:solidFill>
                 <a:latin typeface="Arial"/>
               </a:rPr>
-              <a:t>Week 8 exit</a:t>
+              <a:t>Week 4 exit</a:t>
             </a:r>
           </a:p>
         </p:txBody>
@@ -21134,7 +21134,7 @@
                 </a:solidFill>
                 <a:latin typeface="Arial"/>
               </a:rPr>
-              <a:t>Notebook — Insert 1</a:t>
+              <a:t>Notes — Insert 1</a:t>
             </a:r>
           </a:p>
         </p:txBody>
@@ -21257,7 +21257,7 @@
                 </a:solidFill>
                 <a:latin typeface="Arial"/>
               </a:rPr>
-              <a:t>NOTEBOOK</a:t>
+              <a:t>NOTES</a:t>
             </a:r>
           </a:p>
         </p:txBody>

</xml_diff>